<commit_message>
Update architecture diagram and PowerPoint
</commit_message>
<xml_diff>
--- a/Architecture.pptx
+++ b/Architecture.pptx
@@ -104,6 +104,11 @@
       </a:defRPr>
     </a:lvl9pPr>
   </p:defaultTextStyle>
+  <p:extLst>
+    <p:ext uri="{EFAFB233-063F-42B5-8137-9DF3F51BA10A}">
+      <p15:sldGuideLst xmlns:p15="http://schemas.microsoft.com/office/powerpoint/2012/main"/>
+    </p:ext>
+  </p:extLst>
 </p:presentation>
 </file>
 
@@ -4172,7 +4177,7 @@
                   <a:sym typeface="Arial"/>
                   <a:rtl val="0"/>
                 </a:rPr>
-                <a:t>東日本</a:t>
+                <a:t>米国東</a:t>
               </a:r>
               <a:endParaRPr lang="ja-JP" altLang="en-US" sz="900" b="1" spc="0" baseline="0" dirty="0">
                 <a:ln/>
@@ -4411,7 +4416,7 @@
                   <a:sym typeface="Arial"/>
                   <a:rtl val="0"/>
                 </a:rPr>
-                <a:t>西日本</a:t>
+                <a:t>米国西</a:t>
               </a:r>
               <a:endParaRPr lang="en-US" altLang="ja-JP" sz="900" b="1" spc="0" baseline="0" dirty="0">
                 <a:ln/>

</xml_diff>